<commit_message>
little-milestones: regenerate deliverables with architecture diagram + split design docs
architecture.pptx now opens with a real box-and-arrow diagram slide
(12 shapes, 8 labeled data-flow arrows: client -> API -> data/external
layers, derived from ARCHITECTURE_KB's component map). design.docx
retired in favor of functional-design.docx (PLAN.md's feature/user-flow
sections + UX_KB.md, 2110 paragraphs) and technical-design.docx
(PLAN.md's tech-stack/data-model sections + ARCHITECTURE_KB.md, 1972
paragraphs), split at paragraph level for mixed sections per the human's
feedback and the updated deliverables-agent conventions.

Co-Authored-By: Claude Sonnet 5 <noreply@anthropic.com>
</commit_message>
<xml_diff>
--- a/projects/little-milestones/deliverables/architecture.pptx
+++ b/projects/little-milestones/deliverables/architecture.pptx
@@ -6,6 +6,7 @@
   </p:sldMasterIdLst>
   <p:sldIdLst>
     <p:sldId id="256" r:id="rId7"/>
+    <p:sldId id="290" r:id="rId41"/>
     <p:sldId id="257" r:id="rId8"/>
     <p:sldId id="258" r:id="rId9"/>
     <p:sldId id="259" r:id="rId10"/>
@@ -7685,6 +7686,1729 @@
             </a:pPr>
             <a:r>
               <a:t>SECURITY_KB.md and RESPONSIBLE_AI_KB.md remain markdown-only in full — this slide is a curated cross-reference, not a substitute for either file.</a:t>
+            </a:r>
+          </a:p>
+        </p:txBody>
+      </p:sp>
+    </p:spTree>
+  </p:cSld>
+  <p:clrMapOvr>
+    <a:masterClrMapping/>
+  </p:clrMapOvr>
+</p:sld>
+</file>
+
+<file path=ppt/slides/slide35.xml><?xml version="1.0" encoding="utf-8"?>
+<p:sld xmlns:a="http://schemas.openxmlformats.org/drawingml/2006/main" xmlns:p="http://schemas.openxmlformats.org/presentationml/2006/main" xmlns:r="http://schemas.openxmlformats.org/officeDocument/2006/relationships">
+  <p:cSld>
+    <p:spTree>
+      <p:nvGrpSpPr>
+        <p:cNvPr id="1" name=""/>
+        <p:cNvGrpSpPr/>
+        <p:nvPr/>
+      </p:nvGrpSpPr>
+      <p:grpSpPr/>
+      <p:sp>
+        <p:nvSpPr>
+          <p:cNvPr id="2" name="TextBox 1"/>
+          <p:cNvSpPr txBox="1"/>
+          <p:nvPr/>
+        </p:nvSpPr>
+        <p:spPr>
+          <a:xfrm>
+            <a:off x="365760" y="182880"/>
+            <a:ext cx="11460175" cy="548640"/>
+          </a:xfrm>
+          <a:prstGeom prst="rect">
+            <a:avLst/>
+          </a:prstGeom>
+          <a:noFill/>
+        </p:spPr>
+        <p:txBody>
+          <a:bodyPr wrap="none">
+            <a:spAutoFit/>
+          </a:bodyPr>
+          <a:lstStyle/>
+          <a:p>
+            <a:pPr>
+              <a:defRPr sz="2400" b="1">
+                <a:solidFill>
+                  <a:srgbClr val="1F3A5F"/>
+                </a:solidFill>
+              </a:defRPr>
+            </a:pPr>
+            <a:r>
+              <a:t>Architecture Diagram — System Components &amp; Data Flow</a:t>
+            </a:r>
+          </a:p>
+        </p:txBody>
+      </p:sp>
+      <p:sp>
+        <p:nvSpPr>
+          <p:cNvPr id="3" name="TextBox 2"/>
+          <p:cNvSpPr txBox="1"/>
+          <p:nvPr/>
+        </p:nvSpPr>
+        <p:spPr>
+          <a:xfrm>
+            <a:off x="365760" y="685800"/>
+            <a:ext cx="11460175" cy="320040"/>
+          </a:xfrm>
+          <a:prstGeom prst="rect">
+            <a:avLst/>
+          </a:prstGeom>
+          <a:noFill/>
+        </p:spPr>
+        <p:txBody>
+          <a:bodyPr wrap="none">
+            <a:spAutoFit/>
+          </a:bodyPr>
+          <a:lstStyle/>
+          <a:p>
+            <a:pPr>
+              <a:defRPr sz="1100" i="1">
+                <a:solidFill>
+                  <a:srgbClr val="606060"/>
+                </a:solidFill>
+              </a:defRPr>
+            </a:pPr>
+            <a:r>
+              <a:t>Derived from ARCHITECTURE_KB.md §0 (component map), §2 (auth), §3 (storage), §5 (email delivery), §6 (output enforcement), §12 (Google Photos import)</a:t>
+            </a:r>
+          </a:p>
+        </p:txBody>
+      </p:sp>
+      <p:sp>
+        <p:nvSpPr>
+          <p:cNvPr id="4" name="Rounded Rectangle 3"/>
+          <p:cNvSpPr/>
+          <p:nvPr/>
+        </p:nvSpPr>
+        <p:spPr>
+          <a:xfrm>
+            <a:off x="4572000" y="1143000"/>
+            <a:ext cx="3017520" cy="640080"/>
+          </a:xfrm>
+          <a:prstGeom prst="roundRect">
+            <a:avLst/>
+          </a:prstGeom>
+          <a:solidFill>
+            <a:srgbClr val="BFDBFE"/>
+          </a:solidFill>
+          <a:ln w="12700">
+            <a:solidFill>
+              <a:srgbClr val="404040"/>
+            </a:solidFill>
+          </a:ln>
+          <a:effectLst/>
+        </p:spPr>
+        <p:style>
+          <a:lnRef idx="1">
+            <a:schemeClr val="accent1"/>
+          </a:lnRef>
+          <a:fillRef idx="3">
+            <a:schemeClr val="accent1"/>
+          </a:fillRef>
+          <a:effectRef idx="2">
+            <a:schemeClr val="accent1"/>
+          </a:effectRef>
+          <a:fontRef idx="minor">
+            <a:schemeClr val="lt1"/>
+          </a:fontRef>
+        </p:style>
+        <p:txBody>
+          <a:bodyPr rtlCol="0" anchor="ctr" wrap="square" lIns="38100" rIns="38100" tIns="25400" bIns="25400"/>
+          <a:lstStyle/>
+          <a:p>
+            <a:pPr algn="ctr">
+              <a:defRPr sz="1100" b="1">
+                <a:solidFill>
+                  <a:srgbClr val="1A1A1A"/>
+                </a:solidFill>
+              </a:defRPr>
+            </a:pPr>
+            <a:r>
+              <a:t>Next.js Frontend (Browser)</a:t>
+            </a:r>
+          </a:p>
+          <a:p>
+            <a:pPr algn="ctr">
+              <a:defRPr sz="900" b="0">
+                <a:solidFill>
+                  <a:srgbClr val="1A1A1A"/>
+                </a:solidFill>
+              </a:defRPr>
+            </a:pPr>
+            <a:r>
+              <a:t>chat / profiles / timeline / photos / auth UI</a:t>
+            </a:r>
+          </a:p>
+        </p:txBody>
+      </p:sp>
+      <p:sp>
+        <p:nvSpPr>
+          <p:cNvPr id="5" name="Rounded Rectangle 4"/>
+          <p:cNvSpPr/>
+          <p:nvPr/>
+        </p:nvSpPr>
+        <p:spPr>
+          <a:xfrm>
+            <a:off x="4206240" y="2331720"/>
+            <a:ext cx="3749039" cy="777240"/>
+          </a:xfrm>
+          <a:prstGeom prst="roundRect">
+            <a:avLst/>
+          </a:prstGeom>
+          <a:solidFill>
+            <a:srgbClr val="FDE68A"/>
+          </a:solidFill>
+          <a:ln w="12700">
+            <a:solidFill>
+              <a:srgbClr val="404040"/>
+            </a:solidFill>
+          </a:ln>
+          <a:effectLst/>
+        </p:spPr>
+        <p:style>
+          <a:lnRef idx="1">
+            <a:schemeClr val="accent1"/>
+          </a:lnRef>
+          <a:fillRef idx="3">
+            <a:schemeClr val="accent1"/>
+          </a:fillRef>
+          <a:effectRef idx="2">
+            <a:schemeClr val="accent1"/>
+          </a:effectRef>
+          <a:fontRef idx="minor">
+            <a:schemeClr val="lt1"/>
+          </a:fontRef>
+        </p:style>
+        <p:txBody>
+          <a:bodyPr rtlCol="0" anchor="ctr" wrap="square" lIns="38100" rIns="38100" tIns="25400" bIns="25400"/>
+          <a:lstStyle/>
+          <a:p>
+            <a:pPr algn="ctr">
+              <a:defRPr sz="1100" b="1">
+                <a:solidFill>
+                  <a:srgbClr val="1A1A1A"/>
+                </a:solidFill>
+              </a:defRPr>
+            </a:pPr>
+            <a:r>
+              <a:t>FastAPI Backend</a:t>
+            </a:r>
+          </a:p>
+          <a:p>
+            <a:pPr algn="ctr">
+              <a:defRPr sz="900" b="0">
+                <a:solidFill>
+                  <a:srgbClr val="1A1A1A"/>
+                </a:solidFill>
+              </a:defRPr>
+            </a:pPr>
+            <a:r>
+              <a:t>main.py + routers (profiles, chat, memories,</a:t>
+            </a:r>
+          </a:p>
+          <a:p>
+            <a:pPr algn="ctr">
+              <a:defRPr sz="900" b="0">
+                <a:solidFill>
+                  <a:srgbClr val="1A1A1A"/>
+                </a:solidFill>
+              </a:defRPr>
+            </a:pPr>
+            <a:r>
+              <a:t>photos, digest, products, auth)</a:t>
+            </a:r>
+          </a:p>
+        </p:txBody>
+      </p:sp>
+      <p:sp>
+        <p:nvSpPr>
+          <p:cNvPr id="6" name="Rounded Rectangle 5"/>
+          <p:cNvSpPr/>
+          <p:nvPr/>
+        </p:nvSpPr>
+        <p:spPr>
+          <a:xfrm>
+            <a:off x="320040" y="2377440"/>
+            <a:ext cx="1828800" cy="685800"/>
+          </a:xfrm>
+          <a:prstGeom prst="roundRect">
+            <a:avLst/>
+          </a:prstGeom>
+          <a:solidFill>
+            <a:srgbClr val="FDE68A"/>
+          </a:solidFill>
+          <a:ln w="12700">
+            <a:solidFill>
+              <a:srgbClr val="404040"/>
+            </a:solidFill>
+          </a:ln>
+          <a:effectLst/>
+        </p:spPr>
+        <p:style>
+          <a:lnRef idx="1">
+            <a:schemeClr val="accent1"/>
+          </a:lnRef>
+          <a:fillRef idx="3">
+            <a:schemeClr val="accent1"/>
+          </a:fillRef>
+          <a:effectRef idx="2">
+            <a:schemeClr val="accent1"/>
+          </a:effectRef>
+          <a:fontRef idx="minor">
+            <a:schemeClr val="lt1"/>
+          </a:fontRef>
+        </p:style>
+        <p:txBody>
+          <a:bodyPr rtlCol="0" anchor="ctr" wrap="square" lIns="38100" rIns="38100" tIns="25400" bIns="25400"/>
+          <a:lstStyle/>
+          <a:p>
+            <a:pPr algn="ctr">
+              <a:defRPr sz="1000" b="1">
+                <a:solidFill>
+                  <a:srgbClr val="1A1A1A"/>
+                </a:solidFill>
+              </a:defRPr>
+            </a:pPr>
+            <a:r>
+              <a:t>guardrails.py</a:t>
+            </a:r>
+          </a:p>
+          <a:p>
+            <a:pPr algn="ctr">
+              <a:defRPr sz="800" b="0">
+                <a:solidFill>
+                  <a:srgbClr val="1A1A1A"/>
+                </a:solidFill>
+              </a:defRPr>
+            </a:pPr>
+            <a:r>
+              <a:t>output-side R1/R2</a:t>
+            </a:r>
+          </a:p>
+          <a:p>
+            <a:pPr algn="ctr">
+              <a:defRPr sz="800" b="0">
+                <a:solidFill>
+                  <a:srgbClr val="1A1A1A"/>
+                </a:solidFill>
+              </a:defRPr>
+            </a:pPr>
+            <a:r>
+              <a:t>enforcement</a:t>
+            </a:r>
+          </a:p>
+        </p:txBody>
+      </p:sp>
+      <p:sp>
+        <p:nvSpPr>
+          <p:cNvPr id="7" name="Rounded Rectangle 6"/>
+          <p:cNvSpPr/>
+          <p:nvPr/>
+        </p:nvSpPr>
+        <p:spPr>
+          <a:xfrm>
+            <a:off x="8961120" y="2377440"/>
+            <a:ext cx="1828800" cy="685800"/>
+          </a:xfrm>
+          <a:prstGeom prst="roundRect">
+            <a:avLst/>
+          </a:prstGeom>
+          <a:solidFill>
+            <a:srgbClr val="FDE68A"/>
+          </a:solidFill>
+          <a:ln w="12700">
+            <a:solidFill>
+              <a:srgbClr val="404040"/>
+            </a:solidFill>
+          </a:ln>
+          <a:effectLst/>
+        </p:spPr>
+        <p:style>
+          <a:lnRef idx="1">
+            <a:schemeClr val="accent1"/>
+          </a:lnRef>
+          <a:fillRef idx="3">
+            <a:schemeClr val="accent1"/>
+          </a:fillRef>
+          <a:effectRef idx="2">
+            <a:schemeClr val="accent1"/>
+          </a:effectRef>
+          <a:fontRef idx="minor">
+            <a:schemeClr val="lt1"/>
+          </a:fontRef>
+        </p:style>
+        <p:txBody>
+          <a:bodyPr rtlCol="0" anchor="ctr" wrap="square" lIns="38100" rIns="38100" tIns="25400" bIns="25400"/>
+          <a:lstStyle/>
+          <a:p>
+            <a:pPr algn="ctr">
+              <a:defRPr sz="1000" b="1">
+                <a:solidFill>
+                  <a:srgbClr val="1A1A1A"/>
+                </a:solidFill>
+              </a:defRPr>
+            </a:pPr>
+            <a:r>
+              <a:t>scheduler.py</a:t>
+            </a:r>
+          </a:p>
+          <a:p>
+            <a:pPr algn="ctr">
+              <a:defRPr sz="800" b="0">
+                <a:solidFill>
+                  <a:srgbClr val="1A1A1A"/>
+                </a:solidFill>
+              </a:defRPr>
+            </a:pPr>
+            <a:r>
+              <a:t>APScheduler</a:t>
+            </a:r>
+          </a:p>
+          <a:p>
+            <a:pPr algn="ctr">
+              <a:defRPr sz="800" b="0">
+                <a:solidFill>
+                  <a:srgbClr val="1A1A1A"/>
+                </a:solidFill>
+              </a:defRPr>
+            </a:pPr>
+            <a:r>
+              <a:t>(in-process, daily digest job)</a:t>
+            </a:r>
+          </a:p>
+        </p:txBody>
+      </p:sp>
+      <p:sp>
+        <p:nvSpPr>
+          <p:cNvPr id="8" name="Rounded Rectangle 7"/>
+          <p:cNvSpPr/>
+          <p:nvPr/>
+        </p:nvSpPr>
+        <p:spPr>
+          <a:xfrm>
+            <a:off x="320040" y="3977639"/>
+            <a:ext cx="1965960" cy="777240"/>
+          </a:xfrm>
+          <a:prstGeom prst="roundRect">
+            <a:avLst/>
+          </a:prstGeom>
+          <a:solidFill>
+            <a:srgbClr val="C8E6C9"/>
+          </a:solidFill>
+          <a:ln w="12700">
+            <a:solidFill>
+              <a:srgbClr val="404040"/>
+            </a:solidFill>
+          </a:ln>
+          <a:effectLst/>
+        </p:spPr>
+        <p:style>
+          <a:lnRef idx="1">
+            <a:schemeClr val="accent1"/>
+          </a:lnRef>
+          <a:fillRef idx="3">
+            <a:schemeClr val="accent1"/>
+          </a:fillRef>
+          <a:effectRef idx="2">
+            <a:schemeClr val="accent1"/>
+          </a:effectRef>
+          <a:fontRef idx="minor">
+            <a:schemeClr val="lt1"/>
+          </a:fontRef>
+        </p:style>
+        <p:txBody>
+          <a:bodyPr rtlCol="0" anchor="ctr" wrap="square" lIns="38100" rIns="38100" tIns="25400" bIns="25400"/>
+          <a:lstStyle/>
+          <a:p>
+            <a:pPr algn="ctr">
+              <a:defRPr sz="900" b="1">
+                <a:solidFill>
+                  <a:srgbClr val="1A1A1A"/>
+                </a:solidFill>
+              </a:defRPr>
+            </a:pPr>
+            <a:r>
+              <a:t>SQLite DB</a:t>
+            </a:r>
+          </a:p>
+          <a:p>
+            <a:pPr algn="ctr">
+              <a:defRPr sz="700" b="0">
+                <a:solidFill>
+                  <a:srgbClr val="1A1A1A"/>
+                </a:solidFill>
+              </a:defRPr>
+            </a:pPr>
+            <a:r>
+              <a:t>little_milestones.db</a:t>
+            </a:r>
+          </a:p>
+          <a:p>
+            <a:pPr algn="ctr">
+              <a:defRPr sz="700" b="0">
+                <a:solidFill>
+                  <a:srgbClr val="1A1A1A"/>
+                </a:solidFill>
+              </a:defRPr>
+            </a:pPr>
+            <a:r>
+              <a:t>(families/users/profiles/</a:t>
+            </a:r>
+          </a:p>
+          <a:p>
+            <a:pPr algn="ctr">
+              <a:defRPr sz="700" b="0">
+                <a:solidFill>
+                  <a:srgbClr val="1A1A1A"/>
+                </a:solidFill>
+              </a:defRPr>
+            </a:pPr>
+            <a:r>
+              <a:t>memories/photo_meta/sessions)</a:t>
+            </a:r>
+          </a:p>
+        </p:txBody>
+      </p:sp>
+      <p:sp>
+        <p:nvSpPr>
+          <p:cNvPr id="9" name="Rounded Rectangle 8"/>
+          <p:cNvSpPr/>
+          <p:nvPr/>
+        </p:nvSpPr>
+        <p:spPr>
+          <a:xfrm>
+            <a:off x="2514600" y="3977639"/>
+            <a:ext cx="1965960" cy="777240"/>
+          </a:xfrm>
+          <a:prstGeom prst="roundRect">
+            <a:avLst/>
+          </a:prstGeom>
+          <a:solidFill>
+            <a:srgbClr val="C8E6C9"/>
+          </a:solidFill>
+          <a:ln w="12700">
+            <a:solidFill>
+              <a:srgbClr val="404040"/>
+            </a:solidFill>
+          </a:ln>
+          <a:effectLst/>
+        </p:spPr>
+        <p:style>
+          <a:lnRef idx="1">
+            <a:schemeClr val="accent1"/>
+          </a:lnRef>
+          <a:fillRef idx="3">
+            <a:schemeClr val="accent1"/>
+          </a:fillRef>
+          <a:effectRef idx="2">
+            <a:schemeClr val="accent1"/>
+          </a:effectRef>
+          <a:fontRef idx="minor">
+            <a:schemeClr val="lt1"/>
+          </a:fontRef>
+        </p:style>
+        <p:txBody>
+          <a:bodyPr rtlCol="0" anchor="ctr" wrap="square" lIns="38100" rIns="38100" tIns="25400" bIns="25400"/>
+          <a:lstStyle/>
+          <a:p>
+            <a:pPr algn="ctr">
+              <a:defRPr sz="900" b="1">
+                <a:solidFill>
+                  <a:srgbClr val="1A1A1A"/>
+                </a:solidFill>
+              </a:defRPr>
+            </a:pPr>
+            <a:r>
+              <a:t>Encrypted Photo Storage</a:t>
+            </a:r>
+          </a:p>
+          <a:p>
+            <a:pPr algn="ctr">
+              <a:defRPr sz="700" b="0">
+                <a:solidFill>
+                  <a:srgbClr val="1A1A1A"/>
+                </a:solidFill>
+              </a:defRPr>
+            </a:pPr>
+            <a:r>
+              <a:t>backend/data/photos/</a:t>
+            </a:r>
+          </a:p>
+          <a:p>
+            <a:pPr algn="ctr">
+              <a:defRPr sz="700" b="0">
+                <a:solidFill>
+                  <a:srgbClr val="1A1A1A"/>
+                </a:solidFill>
+              </a:defRPr>
+            </a:pPr>
+            <a:r>
+              <a:t>(Fernet-encrypted files)</a:t>
+            </a:r>
+          </a:p>
+        </p:txBody>
+      </p:sp>
+      <p:sp>
+        <p:nvSpPr>
+          <p:cNvPr id="10" name="Rounded Rectangle 9"/>
+          <p:cNvSpPr/>
+          <p:nvPr/>
+        </p:nvSpPr>
+        <p:spPr>
+          <a:xfrm>
+            <a:off x="4709160" y="3977639"/>
+            <a:ext cx="1965960" cy="777240"/>
+          </a:xfrm>
+          <a:prstGeom prst="roundRect">
+            <a:avLst/>
+          </a:prstGeom>
+          <a:solidFill>
+            <a:srgbClr val="C8E6C9"/>
+          </a:solidFill>
+          <a:ln w="12700">
+            <a:solidFill>
+              <a:srgbClr val="404040"/>
+            </a:solidFill>
+          </a:ln>
+          <a:effectLst/>
+        </p:spPr>
+        <p:style>
+          <a:lnRef idx="1">
+            <a:schemeClr val="accent1"/>
+          </a:lnRef>
+          <a:fillRef idx="3">
+            <a:schemeClr val="accent1"/>
+          </a:fillRef>
+          <a:effectRef idx="2">
+            <a:schemeClr val="accent1"/>
+          </a:effectRef>
+          <a:fontRef idx="minor">
+            <a:schemeClr val="lt1"/>
+          </a:fontRef>
+        </p:style>
+        <p:txBody>
+          <a:bodyPr rtlCol="0" anchor="ctr" wrap="square" lIns="38100" rIns="38100" tIns="25400" bIns="25400"/>
+          <a:lstStyle/>
+          <a:p>
+            <a:pPr algn="ctr">
+              <a:defRPr sz="900" b="1">
+                <a:solidFill>
+                  <a:srgbClr val="1A1A1A"/>
+                </a:solidFill>
+              </a:defRPr>
+            </a:pPr>
+            <a:r>
+              <a:t>LLM Provider</a:t>
+            </a:r>
+          </a:p>
+          <a:p>
+            <a:pPr algn="ctr">
+              <a:defRPr sz="700" b="0">
+                <a:solidFill>
+                  <a:srgbClr val="1A1A1A"/>
+                </a:solidFill>
+              </a:defRPr>
+            </a:pPr>
+            <a:r>
+              <a:t>Anthropic / OpenAI</a:t>
+            </a:r>
+          </a:p>
+          <a:p>
+            <a:pPr algn="ctr">
+              <a:defRPr sz="700" b="0">
+                <a:solidFill>
+                  <a:srgbClr val="1A1A1A"/>
+                </a:solidFill>
+              </a:defRPr>
+            </a:pPr>
+            <a:r>
+              <a:t>(llm.py provider switch)</a:t>
+            </a:r>
+          </a:p>
+        </p:txBody>
+      </p:sp>
+      <p:sp>
+        <p:nvSpPr>
+          <p:cNvPr id="11" name="Rounded Rectangle 10"/>
+          <p:cNvSpPr/>
+          <p:nvPr/>
+        </p:nvSpPr>
+        <p:spPr>
+          <a:xfrm>
+            <a:off x="6903720" y="3977639"/>
+            <a:ext cx="1828800" cy="777240"/>
+          </a:xfrm>
+          <a:prstGeom prst="roundRect">
+            <a:avLst/>
+          </a:prstGeom>
+          <a:solidFill>
+            <a:srgbClr val="C8E6C9"/>
+          </a:solidFill>
+          <a:ln w="12700">
+            <a:solidFill>
+              <a:srgbClr val="404040"/>
+            </a:solidFill>
+          </a:ln>
+          <a:effectLst/>
+        </p:spPr>
+        <p:style>
+          <a:lnRef idx="1">
+            <a:schemeClr val="accent1"/>
+          </a:lnRef>
+          <a:fillRef idx="3">
+            <a:schemeClr val="accent1"/>
+          </a:fillRef>
+          <a:effectRef idx="2">
+            <a:schemeClr val="accent1"/>
+          </a:effectRef>
+          <a:fontRef idx="minor">
+            <a:schemeClr val="lt1"/>
+          </a:fontRef>
+        </p:style>
+        <p:txBody>
+          <a:bodyPr rtlCol="0" anchor="ctr" wrap="square" lIns="38100" rIns="38100" tIns="25400" bIns="25400"/>
+          <a:lstStyle/>
+          <a:p>
+            <a:pPr algn="ctr">
+              <a:defRPr sz="900" b="1">
+                <a:solidFill>
+                  <a:srgbClr val="1A1A1A"/>
+                </a:solidFill>
+              </a:defRPr>
+            </a:pPr>
+            <a:r>
+              <a:t>Resend</a:t>
+            </a:r>
+          </a:p>
+          <a:p>
+            <a:pPr algn="ctr">
+              <a:defRPr sz="700" b="0">
+                <a:solidFill>
+                  <a:srgbClr val="1A1A1A"/>
+                </a:solidFill>
+              </a:defRPr>
+            </a:pPr>
+            <a:r>
+              <a:t>(transactional email API,</a:t>
+            </a:r>
+          </a:p>
+          <a:p>
+            <a:pPr algn="ctr">
+              <a:defRPr sz="700" b="0">
+                <a:solidFill>
+                  <a:srgbClr val="1A1A1A"/>
+                </a:solidFill>
+              </a:defRPr>
+            </a:pPr>
+            <a:r>
+              <a:t>weekly digest delivery)</a:t>
+            </a:r>
+          </a:p>
+        </p:txBody>
+      </p:sp>
+      <p:sp>
+        <p:nvSpPr>
+          <p:cNvPr id="12" name="Rounded Rectangle 11"/>
+          <p:cNvSpPr/>
+          <p:nvPr/>
+        </p:nvSpPr>
+        <p:spPr>
+          <a:xfrm>
+            <a:off x="9006840" y="3977639"/>
+            <a:ext cx="1828800" cy="777240"/>
+          </a:xfrm>
+          <a:prstGeom prst="roundRect">
+            <a:avLst/>
+          </a:prstGeom>
+          <a:solidFill>
+            <a:srgbClr val="C8E6C9"/>
+          </a:solidFill>
+          <a:ln w="12700">
+            <a:solidFill>
+              <a:srgbClr val="404040"/>
+            </a:solidFill>
+          </a:ln>
+          <a:effectLst/>
+        </p:spPr>
+        <p:style>
+          <a:lnRef idx="1">
+            <a:schemeClr val="accent1"/>
+          </a:lnRef>
+          <a:fillRef idx="3">
+            <a:schemeClr val="accent1"/>
+          </a:fillRef>
+          <a:effectRef idx="2">
+            <a:schemeClr val="accent1"/>
+          </a:effectRef>
+          <a:fontRef idx="minor">
+            <a:schemeClr val="lt1"/>
+          </a:fontRef>
+        </p:style>
+        <p:txBody>
+          <a:bodyPr rtlCol="0" anchor="ctr" wrap="square" lIns="38100" rIns="38100" tIns="25400" bIns="25400"/>
+          <a:lstStyle/>
+          <a:p>
+            <a:pPr algn="ctr">
+              <a:defRPr sz="900" b="1">
+                <a:solidFill>
+                  <a:srgbClr val="1A1A1A"/>
+                </a:solidFill>
+              </a:defRPr>
+            </a:pPr>
+            <a:r>
+              <a:t>Google Photos API</a:t>
+            </a:r>
+          </a:p>
+          <a:p>
+            <a:pPr algn="ctr">
+              <a:defRPr sz="700" b="0">
+                <a:solidFill>
+                  <a:srgbClr val="1A1A1A"/>
+                </a:solidFill>
+              </a:defRPr>
+            </a:pPr>
+            <a:r>
+              <a:t>OAuth2 (authz-code+PKCE)</a:t>
+            </a:r>
+          </a:p>
+          <a:p>
+            <a:pPr algn="ctr">
+              <a:defRPr sz="700" b="0">
+                <a:solidFill>
+                  <a:srgbClr val="1A1A1A"/>
+                </a:solidFill>
+              </a:defRPr>
+            </a:pPr>
+            <a:r>
+              <a:t>+ Picker API</a:t>
+            </a:r>
+          </a:p>
+        </p:txBody>
+      </p:sp>
+      <p:cxnSp>
+        <p:nvCxnSpPr>
+          <p:cNvPr id="13" name="Connector 12"/>
+          <p:cNvCxnSpPr/>
+          <p:nvPr/>
+        </p:nvCxnSpPr>
+        <p:spPr>
+          <a:xfrm flipH="1">
+            <a:off x="6080759" y="1783080"/>
+            <a:ext cx="1" cy="548640"/>
+          </a:xfrm>
+          <a:prstGeom prst="line">
+            <a:avLst/>
+          </a:prstGeom>
+          <a:ln w="15875">
+            <a:solidFill>
+              <a:srgbClr val="333333"/>
+            </a:solidFill>
+            <a:tailEnd type="triangle" w="med" len="med"/>
+          </a:ln>
+        </p:spPr>
+        <p:style>
+          <a:lnRef idx="2">
+            <a:schemeClr val="accent1"/>
+          </a:lnRef>
+          <a:fillRef idx="0">
+            <a:schemeClr val="accent1"/>
+          </a:fillRef>
+          <a:effectRef idx="1">
+            <a:schemeClr val="accent1"/>
+          </a:effectRef>
+          <a:fontRef idx="minor">
+            <a:schemeClr val="tx1"/>
+          </a:fontRef>
+        </p:style>
+      </p:cxnSp>
+      <p:sp>
+        <p:nvSpPr>
+          <p:cNvPr id="14" name="TextBox 13"/>
+          <p:cNvSpPr txBox="1"/>
+          <p:nvPr/>
+        </p:nvSpPr>
+        <p:spPr>
+          <a:xfrm>
+            <a:off x="5166359" y="1929384"/>
+            <a:ext cx="1828800" cy="256032"/>
+          </a:xfrm>
+          <a:prstGeom prst="rect">
+            <a:avLst/>
+          </a:prstGeom>
+          <a:solidFill>
+            <a:srgbClr val="FFFFFF"/>
+          </a:solidFill>
+          <a:ln>
+            <a:noFill/>
+          </a:ln>
+        </p:spPr>
+        <p:txBody>
+          <a:bodyPr wrap="square" lIns="0" rIns="0" tIns="0" bIns="0">
+            <a:spAutoFit/>
+          </a:bodyPr>
+          <a:lstStyle/>
+          <a:p>
+            <a:pPr algn="ctr">
+              <a:defRPr sz="800">
+                <a:solidFill>
+                  <a:srgbClr val="004080"/>
+                </a:solidFill>
+              </a:defRPr>
+            </a:pPr>
+            <a:r>
+              <a:t>HTTPS/JSON</a:t>
+            </a:r>
+            <a:br/>
+            <a:r>
+              <a:t>(REST + streaming chat)</a:t>
+            </a:r>
+          </a:p>
+        </p:txBody>
+      </p:sp>
+      <p:cxnSp>
+        <p:nvCxnSpPr>
+          <p:cNvPr id="15" name="Connector 14"/>
+          <p:cNvCxnSpPr/>
+          <p:nvPr/>
+        </p:nvCxnSpPr>
+        <p:spPr>
+          <a:xfrm flipH="1">
+            <a:off x="2148840" y="2720340"/>
+            <a:ext cx="2057400" cy="0"/>
+          </a:xfrm>
+          <a:prstGeom prst="line">
+            <a:avLst/>
+          </a:prstGeom>
+          <a:ln w="15875">
+            <a:solidFill>
+              <a:srgbClr val="333333"/>
+            </a:solidFill>
+            <a:tailEnd type="triangle" w="med" len="med"/>
+          </a:ln>
+        </p:spPr>
+        <p:style>
+          <a:lnRef idx="2">
+            <a:schemeClr val="accent1"/>
+          </a:lnRef>
+          <a:fillRef idx="0">
+            <a:schemeClr val="accent1"/>
+          </a:fillRef>
+          <a:effectRef idx="1">
+            <a:schemeClr val="accent1"/>
+          </a:effectRef>
+          <a:fontRef idx="minor">
+            <a:schemeClr val="tx1"/>
+          </a:fontRef>
+        </p:style>
+      </p:cxnSp>
+      <p:sp>
+        <p:nvSpPr>
+          <p:cNvPr id="16" name="TextBox 15"/>
+          <p:cNvSpPr txBox="1"/>
+          <p:nvPr/>
+        </p:nvSpPr>
+        <p:spPr>
+          <a:xfrm>
+            <a:off x="2263140" y="2592324"/>
+            <a:ext cx="1828800" cy="256032"/>
+          </a:xfrm>
+          <a:prstGeom prst="rect">
+            <a:avLst/>
+          </a:prstGeom>
+          <a:solidFill>
+            <a:srgbClr val="FFFFFF"/>
+          </a:solidFill>
+          <a:ln>
+            <a:noFill/>
+          </a:ln>
+        </p:spPr>
+        <p:txBody>
+          <a:bodyPr wrap="square" lIns="0" rIns="0" tIns="0" bIns="0">
+            <a:spAutoFit/>
+          </a:bodyPr>
+          <a:lstStyle/>
+          <a:p>
+            <a:pPr algn="ctr">
+              <a:defRPr sz="800">
+                <a:solidFill>
+                  <a:srgbClr val="004080"/>
+                </a:solidFill>
+              </a:defRPr>
+            </a:pPr>
+            <a:r>
+              <a:t>output text</a:t>
+            </a:r>
+            <a:br/>
+            <a:r>
+              <a:t>(framing/medical check)</a:t>
+            </a:r>
+          </a:p>
+        </p:txBody>
+      </p:sp>
+      <p:cxnSp>
+        <p:nvCxnSpPr>
+          <p:cNvPr id="17" name="Connector 16"/>
+          <p:cNvCxnSpPr/>
+          <p:nvPr/>
+        </p:nvCxnSpPr>
+        <p:spPr>
+          <a:xfrm flipH="1">
+            <a:off x="7955279" y="2720340"/>
+            <a:ext cx="1005841" cy="0"/>
+          </a:xfrm>
+          <a:prstGeom prst="line">
+            <a:avLst/>
+          </a:prstGeom>
+          <a:ln w="15875">
+            <a:solidFill>
+              <a:srgbClr val="333333"/>
+            </a:solidFill>
+            <a:tailEnd type="triangle" w="med" len="med"/>
+          </a:ln>
+        </p:spPr>
+        <p:style>
+          <a:lnRef idx="2">
+            <a:schemeClr val="accent1"/>
+          </a:lnRef>
+          <a:fillRef idx="0">
+            <a:schemeClr val="accent1"/>
+          </a:fillRef>
+          <a:effectRef idx="1">
+            <a:schemeClr val="accent1"/>
+          </a:effectRef>
+          <a:fontRef idx="minor">
+            <a:schemeClr val="tx1"/>
+          </a:fontRef>
+        </p:style>
+      </p:cxnSp>
+      <p:sp>
+        <p:nvSpPr>
+          <p:cNvPr id="18" name="TextBox 17"/>
+          <p:cNvSpPr txBox="1"/>
+          <p:nvPr/>
+        </p:nvSpPr>
+        <p:spPr>
+          <a:xfrm>
+            <a:off x="7543799" y="2592324"/>
+            <a:ext cx="1828800" cy="256032"/>
+          </a:xfrm>
+          <a:prstGeom prst="rect">
+            <a:avLst/>
+          </a:prstGeom>
+          <a:solidFill>
+            <a:srgbClr val="FFFFFF"/>
+          </a:solidFill>
+          <a:ln>
+            <a:noFill/>
+          </a:ln>
+        </p:spPr>
+        <p:txBody>
+          <a:bodyPr wrap="square" lIns="0" rIns="0" tIns="0" bIns="0">
+            <a:spAutoFit/>
+          </a:bodyPr>
+          <a:lstStyle/>
+          <a:p>
+            <a:pPr algn="ctr">
+              <a:defRPr sz="800">
+                <a:solidFill>
+                  <a:srgbClr val="004080"/>
+                </a:solidFill>
+              </a:defRPr>
+            </a:pPr>
+            <a:r>
+              <a:t>digest trigger</a:t>
+            </a:r>
+            <a:br/>
+            <a:r>
+              <a:t>(daily job)</a:t>
+            </a:r>
+          </a:p>
+        </p:txBody>
+      </p:sp>
+      <p:cxnSp>
+        <p:nvCxnSpPr>
+          <p:cNvPr id="19" name="Connector 18"/>
+          <p:cNvCxnSpPr/>
+          <p:nvPr/>
+        </p:nvCxnSpPr>
+        <p:spPr>
+          <a:xfrm flipH="1">
+            <a:off x="1303020" y="3108960"/>
+            <a:ext cx="4777739" cy="868679"/>
+          </a:xfrm>
+          <a:prstGeom prst="line">
+            <a:avLst/>
+          </a:prstGeom>
+          <a:ln w="15875">
+            <a:solidFill>
+              <a:srgbClr val="333333"/>
+            </a:solidFill>
+            <a:tailEnd type="triangle" w="med" len="med"/>
+          </a:ln>
+        </p:spPr>
+        <p:style>
+          <a:lnRef idx="2">
+            <a:schemeClr val="accent1"/>
+          </a:lnRef>
+          <a:fillRef idx="0">
+            <a:schemeClr val="accent1"/>
+          </a:fillRef>
+          <a:effectRef idx="1">
+            <a:schemeClr val="accent1"/>
+          </a:effectRef>
+          <a:fontRef idx="minor">
+            <a:schemeClr val="tx1"/>
+          </a:fontRef>
+        </p:style>
+      </p:cxnSp>
+      <p:sp>
+        <p:nvSpPr>
+          <p:cNvPr id="20" name="TextBox 19"/>
+          <p:cNvSpPr txBox="1"/>
+          <p:nvPr/>
+        </p:nvSpPr>
+        <p:spPr>
+          <a:xfrm>
+            <a:off x="2777489" y="3415283"/>
+            <a:ext cx="1828800" cy="256032"/>
+          </a:xfrm>
+          <a:prstGeom prst="rect">
+            <a:avLst/>
+          </a:prstGeom>
+          <a:solidFill>
+            <a:srgbClr val="FFFFFF"/>
+          </a:solidFill>
+          <a:ln>
+            <a:noFill/>
+          </a:ln>
+        </p:spPr>
+        <p:txBody>
+          <a:bodyPr wrap="square" lIns="0" rIns="0" tIns="0" bIns="0">
+            <a:spAutoFit/>
+          </a:bodyPr>
+          <a:lstStyle/>
+          <a:p>
+            <a:pPr algn="ctr">
+              <a:defRPr sz="800">
+                <a:solidFill>
+                  <a:srgbClr val="004080"/>
+                </a:solidFill>
+              </a:defRPr>
+            </a:pPr>
+            <a:r>
+              <a:t>SQL (Store</a:t>
+            </a:r>
+            <a:br/>
+            <a:r>
+              <a:t>interfaces)</a:t>
+            </a:r>
+          </a:p>
+        </p:txBody>
+      </p:sp>
+      <p:cxnSp>
+        <p:nvCxnSpPr>
+          <p:cNvPr id="21" name="Connector 20"/>
+          <p:cNvCxnSpPr/>
+          <p:nvPr/>
+        </p:nvCxnSpPr>
+        <p:spPr>
+          <a:xfrm flipH="1">
+            <a:off x="3497580" y="3108960"/>
+            <a:ext cx="2583179" cy="868679"/>
+          </a:xfrm>
+          <a:prstGeom prst="line">
+            <a:avLst/>
+          </a:prstGeom>
+          <a:ln w="15875">
+            <a:solidFill>
+              <a:srgbClr val="333333"/>
+            </a:solidFill>
+            <a:tailEnd type="triangle" w="med" len="med"/>
+          </a:ln>
+        </p:spPr>
+        <p:style>
+          <a:lnRef idx="2">
+            <a:schemeClr val="accent1"/>
+          </a:lnRef>
+          <a:fillRef idx="0">
+            <a:schemeClr val="accent1"/>
+          </a:fillRef>
+          <a:effectRef idx="1">
+            <a:schemeClr val="accent1"/>
+          </a:effectRef>
+          <a:fontRef idx="minor">
+            <a:schemeClr val="tx1"/>
+          </a:fontRef>
+        </p:style>
+      </p:cxnSp>
+      <p:sp>
+        <p:nvSpPr>
+          <p:cNvPr id="22" name="TextBox 21"/>
+          <p:cNvSpPr txBox="1"/>
+          <p:nvPr/>
+        </p:nvSpPr>
+        <p:spPr>
+          <a:xfrm>
+            <a:off x="3874769" y="3415283"/>
+            <a:ext cx="1828800" cy="256032"/>
+          </a:xfrm>
+          <a:prstGeom prst="rect">
+            <a:avLst/>
+          </a:prstGeom>
+          <a:solidFill>
+            <a:srgbClr val="FFFFFF"/>
+          </a:solidFill>
+          <a:ln>
+            <a:noFill/>
+          </a:ln>
+        </p:spPr>
+        <p:txBody>
+          <a:bodyPr wrap="square" lIns="0" rIns="0" tIns="0" bIns="0">
+            <a:spAutoFit/>
+          </a:bodyPr>
+          <a:lstStyle/>
+          <a:p>
+            <a:pPr algn="ctr">
+              <a:defRPr sz="800">
+                <a:solidFill>
+                  <a:srgbClr val="004080"/>
+                </a:solidFill>
+              </a:defRPr>
+            </a:pPr>
+            <a:r>
+              <a:t>encrypted photo</a:t>
+            </a:r>
+            <a:br/>
+            <a:r>
+              <a:t>bytes (Fernet)</a:t>
+            </a:r>
+          </a:p>
+        </p:txBody>
+      </p:sp>
+      <p:cxnSp>
+        <p:nvCxnSpPr>
+          <p:cNvPr id="23" name="Connector 22"/>
+          <p:cNvCxnSpPr/>
+          <p:nvPr/>
+        </p:nvCxnSpPr>
+        <p:spPr>
+          <a:xfrm flipH="1">
+            <a:off x="5692140" y="3108960"/>
+            <a:ext cx="388619" cy="868679"/>
+          </a:xfrm>
+          <a:prstGeom prst="line">
+            <a:avLst/>
+          </a:prstGeom>
+          <a:ln w="15875">
+            <a:solidFill>
+              <a:srgbClr val="333333"/>
+            </a:solidFill>
+            <a:tailEnd type="triangle" w="med" len="med"/>
+          </a:ln>
+        </p:spPr>
+        <p:style>
+          <a:lnRef idx="2">
+            <a:schemeClr val="accent1"/>
+          </a:lnRef>
+          <a:fillRef idx="0">
+            <a:schemeClr val="accent1"/>
+          </a:fillRef>
+          <a:effectRef idx="1">
+            <a:schemeClr val="accent1"/>
+          </a:effectRef>
+          <a:fontRef idx="minor">
+            <a:schemeClr val="tx1"/>
+          </a:fontRef>
+        </p:style>
+      </p:cxnSp>
+      <p:sp>
+        <p:nvSpPr>
+          <p:cNvPr id="24" name="TextBox 23"/>
+          <p:cNvSpPr txBox="1"/>
+          <p:nvPr/>
+        </p:nvSpPr>
+        <p:spPr>
+          <a:xfrm>
+            <a:off x="4972049" y="3415283"/>
+            <a:ext cx="1828800" cy="256032"/>
+          </a:xfrm>
+          <a:prstGeom prst="rect">
+            <a:avLst/>
+          </a:prstGeom>
+          <a:solidFill>
+            <a:srgbClr val="FFFFFF"/>
+          </a:solidFill>
+          <a:ln>
+            <a:noFill/>
+          </a:ln>
+        </p:spPr>
+        <p:txBody>
+          <a:bodyPr wrap="square" lIns="0" rIns="0" tIns="0" bIns="0">
+            <a:spAutoFit/>
+          </a:bodyPr>
+          <a:lstStyle/>
+          <a:p>
+            <a:pPr algn="ctr">
+              <a:defRPr sz="800">
+                <a:solidFill>
+                  <a:srgbClr val="004080"/>
+                </a:solidFill>
+              </a:defRPr>
+            </a:pPr>
+            <a:r>
+              <a:t>LLM API call</a:t>
+            </a:r>
+            <a:br/>
+            <a:r>
+              <a:t>(guarded system prompt)</a:t>
+            </a:r>
+          </a:p>
+        </p:txBody>
+      </p:sp>
+      <p:cxnSp>
+        <p:nvCxnSpPr>
+          <p:cNvPr id="25" name="Connector 24"/>
+          <p:cNvCxnSpPr/>
+          <p:nvPr/>
+        </p:nvCxnSpPr>
+        <p:spPr>
+          <a:xfrm flipH="1">
+            <a:off x="7818120" y="3063240"/>
+            <a:ext cx="2057400" cy="914399"/>
+          </a:xfrm>
+          <a:prstGeom prst="line">
+            <a:avLst/>
+          </a:prstGeom>
+          <a:ln w="15875">
+            <a:solidFill>
+              <a:srgbClr val="333333"/>
+            </a:solidFill>
+            <a:tailEnd type="triangle" w="med" len="med"/>
+          </a:ln>
+        </p:spPr>
+        <p:style>
+          <a:lnRef idx="2">
+            <a:schemeClr val="accent1"/>
+          </a:lnRef>
+          <a:fillRef idx="0">
+            <a:schemeClr val="accent1"/>
+          </a:fillRef>
+          <a:effectRef idx="1">
+            <a:schemeClr val="accent1"/>
+          </a:effectRef>
+          <a:fontRef idx="minor">
+            <a:schemeClr val="tx1"/>
+          </a:fontRef>
+        </p:style>
+      </p:cxnSp>
+      <p:sp>
+        <p:nvSpPr>
+          <p:cNvPr id="26" name="TextBox 25"/>
+          <p:cNvSpPr txBox="1"/>
+          <p:nvPr/>
+        </p:nvSpPr>
+        <p:spPr>
+          <a:xfrm>
+            <a:off x="7932420" y="3392423"/>
+            <a:ext cx="1828800" cy="256032"/>
+          </a:xfrm>
+          <a:prstGeom prst="rect">
+            <a:avLst/>
+          </a:prstGeom>
+          <a:solidFill>
+            <a:srgbClr val="FFFFFF"/>
+          </a:solidFill>
+          <a:ln>
+            <a:noFill/>
+          </a:ln>
+        </p:spPr>
+        <p:txBody>
+          <a:bodyPr wrap="square" lIns="0" rIns="0" tIns="0" bIns="0">
+            <a:spAutoFit/>
+          </a:bodyPr>
+          <a:lstStyle/>
+          <a:p>
+            <a:pPr algn="ctr">
+              <a:defRPr sz="800">
+                <a:solidFill>
+                  <a:srgbClr val="004080"/>
+                </a:solidFill>
+              </a:defRPr>
+            </a:pPr>
+            <a:r>
+              <a:t>email API</a:t>
+            </a:r>
+            <a:br/>
+            <a:r>
+              <a:t>(digest send)</a:t>
+            </a:r>
+          </a:p>
+        </p:txBody>
+      </p:sp>
+      <p:cxnSp>
+        <p:nvCxnSpPr>
+          <p:cNvPr id="27" name="Connector 26"/>
+          <p:cNvCxnSpPr/>
+          <p:nvPr/>
+        </p:nvCxnSpPr>
+        <p:spPr>
+          <a:xfrm>
+            <a:off x="7955279" y="2720340"/>
+            <a:ext cx="1965961" cy="1257299"/>
+          </a:xfrm>
+          <a:prstGeom prst="line">
+            <a:avLst/>
+          </a:prstGeom>
+          <a:ln w="15875">
+            <a:solidFill>
+              <a:srgbClr val="333333"/>
+            </a:solidFill>
+            <a:tailEnd type="triangle" w="med" len="med"/>
+          </a:ln>
+        </p:spPr>
+        <p:style>
+          <a:lnRef idx="2">
+            <a:schemeClr val="accent1"/>
+          </a:lnRef>
+          <a:fillRef idx="0">
+            <a:schemeClr val="accent1"/>
+          </a:fillRef>
+          <a:effectRef idx="1">
+            <a:schemeClr val="accent1"/>
+          </a:effectRef>
+          <a:fontRef idx="minor">
+            <a:schemeClr val="tx1"/>
+          </a:fontRef>
+        </p:style>
+      </p:cxnSp>
+      <p:sp>
+        <p:nvSpPr>
+          <p:cNvPr id="28" name="TextBox 27"/>
+          <p:cNvSpPr txBox="1"/>
+          <p:nvPr/>
+        </p:nvSpPr>
+        <p:spPr>
+          <a:xfrm>
+            <a:off x="8023859" y="3220973"/>
+            <a:ext cx="1828800" cy="256032"/>
+          </a:xfrm>
+          <a:prstGeom prst="rect">
+            <a:avLst/>
+          </a:prstGeom>
+          <a:solidFill>
+            <a:srgbClr val="FFFFFF"/>
+          </a:solidFill>
+          <a:ln>
+            <a:noFill/>
+          </a:ln>
+        </p:spPr>
+        <p:txBody>
+          <a:bodyPr wrap="square" lIns="0" rIns="0" tIns="0" bIns="0">
+            <a:spAutoFit/>
+          </a:bodyPr>
+          <a:lstStyle/>
+          <a:p>
+            <a:pPr algn="ctr">
+              <a:defRPr sz="800">
+                <a:solidFill>
+                  <a:srgbClr val="004080"/>
+                </a:solidFill>
+              </a:defRPr>
+            </a:pPr>
+            <a:r>
+              <a:t>OAuth2 + Picker</a:t>
+            </a:r>
+            <a:br/>
+            <a:r>
+              <a:t>session (F17)</a:t>
+            </a:r>
+          </a:p>
+        </p:txBody>
+      </p:sp>
+      <p:sp>
+        <p:nvSpPr>
+          <p:cNvPr id="29" name="Rounded Rectangle 28"/>
+          <p:cNvSpPr/>
+          <p:nvPr/>
+        </p:nvSpPr>
+        <p:spPr>
+          <a:xfrm>
+            <a:off x="320040" y="5074920"/>
+            <a:ext cx="320040" cy="256032"/>
+          </a:xfrm>
+          <a:prstGeom prst="roundRect">
+            <a:avLst/>
+          </a:prstGeom>
+          <a:solidFill>
+            <a:srgbClr val="BFDBFE"/>
+          </a:solidFill>
+          <a:ln w="12700">
+            <a:solidFill>
+              <a:srgbClr val="404040"/>
+            </a:solidFill>
+          </a:ln>
+          <a:effectLst/>
+        </p:spPr>
+        <p:style>
+          <a:lnRef idx="1">
+            <a:schemeClr val="accent1"/>
+          </a:lnRef>
+          <a:fillRef idx="3">
+            <a:schemeClr val="accent1"/>
+          </a:fillRef>
+          <a:effectRef idx="2">
+            <a:schemeClr val="accent1"/>
+          </a:effectRef>
+          <a:fontRef idx="minor">
+            <a:schemeClr val="lt1"/>
+          </a:fontRef>
+        </p:style>
+        <p:txBody>
+          <a:bodyPr rtlCol="0" anchor="ctr" wrap="square" lIns="38100" rIns="38100" tIns="25400" bIns="25400"/>
+          <a:lstStyle/>
+          <a:p>
+            <a:pPr algn="ctr">
+              <a:defRPr sz="800" b="1">
+                <a:solidFill>
+                  <a:srgbClr val="1A1A1A"/>
+                </a:solidFill>
+              </a:defRPr>
+            </a:pPr>
+          </a:p>
+        </p:txBody>
+      </p:sp>
+      <p:sp>
+        <p:nvSpPr>
+          <p:cNvPr id="30" name="TextBox 29"/>
+          <p:cNvSpPr txBox="1"/>
+          <p:nvPr/>
+        </p:nvSpPr>
+        <p:spPr>
+          <a:xfrm>
+            <a:off x="685800" y="5056632"/>
+            <a:ext cx="2286000" cy="274320"/>
+          </a:xfrm>
+          <a:prstGeom prst="rect">
+            <a:avLst/>
+          </a:prstGeom>
+          <a:noFill/>
+        </p:spPr>
+        <p:txBody>
+          <a:bodyPr wrap="none">
+            <a:spAutoFit/>
+          </a:bodyPr>
+          <a:lstStyle/>
+          <a:p>
+            <a:pPr>
+              <a:defRPr sz="1000"/>
+            </a:pPr>
+            <a:r>
+              <a:t>Client layer</a:t>
+            </a:r>
+          </a:p>
+        </p:txBody>
+      </p:sp>
+      <p:sp>
+        <p:nvSpPr>
+          <p:cNvPr id="31" name="Rounded Rectangle 30"/>
+          <p:cNvSpPr/>
+          <p:nvPr/>
+        </p:nvSpPr>
+        <p:spPr>
+          <a:xfrm>
+            <a:off x="2194560" y="5074920"/>
+            <a:ext cx="320040" cy="256032"/>
+          </a:xfrm>
+          <a:prstGeom prst="roundRect">
+            <a:avLst/>
+          </a:prstGeom>
+          <a:solidFill>
+            <a:srgbClr val="FDE68A"/>
+          </a:solidFill>
+          <a:ln w="12700">
+            <a:solidFill>
+              <a:srgbClr val="404040"/>
+            </a:solidFill>
+          </a:ln>
+          <a:effectLst/>
+        </p:spPr>
+        <p:style>
+          <a:lnRef idx="1">
+            <a:schemeClr val="accent1"/>
+          </a:lnRef>
+          <a:fillRef idx="3">
+            <a:schemeClr val="accent1"/>
+          </a:fillRef>
+          <a:effectRef idx="2">
+            <a:schemeClr val="accent1"/>
+          </a:effectRef>
+          <a:fontRef idx="minor">
+            <a:schemeClr val="lt1"/>
+          </a:fontRef>
+        </p:style>
+        <p:txBody>
+          <a:bodyPr rtlCol="0" anchor="ctr" wrap="square" lIns="38100" rIns="38100" tIns="25400" bIns="25400"/>
+          <a:lstStyle/>
+          <a:p>
+            <a:pPr algn="ctr">
+              <a:defRPr sz="800" b="1">
+                <a:solidFill>
+                  <a:srgbClr val="1A1A1A"/>
+                </a:solidFill>
+              </a:defRPr>
+            </a:pPr>
+          </a:p>
+        </p:txBody>
+      </p:sp>
+      <p:sp>
+        <p:nvSpPr>
+          <p:cNvPr id="32" name="TextBox 31"/>
+          <p:cNvSpPr txBox="1"/>
+          <p:nvPr/>
+        </p:nvSpPr>
+        <p:spPr>
+          <a:xfrm>
+            <a:off x="2560320" y="5056632"/>
+            <a:ext cx="2286000" cy="274320"/>
+          </a:xfrm>
+          <a:prstGeom prst="rect">
+            <a:avLst/>
+          </a:prstGeom>
+          <a:noFill/>
+        </p:spPr>
+        <p:txBody>
+          <a:bodyPr wrap="none">
+            <a:spAutoFit/>
+          </a:bodyPr>
+          <a:lstStyle/>
+          <a:p>
+            <a:pPr>
+              <a:defRPr sz="1000"/>
+            </a:pPr>
+            <a:r>
+              <a:t>API / backend layer</a:t>
+            </a:r>
+          </a:p>
+        </p:txBody>
+      </p:sp>
+      <p:sp>
+        <p:nvSpPr>
+          <p:cNvPr id="33" name="Rounded Rectangle 32"/>
+          <p:cNvSpPr/>
+          <p:nvPr/>
+        </p:nvSpPr>
+        <p:spPr>
+          <a:xfrm>
+            <a:off x="4480560" y="5074920"/>
+            <a:ext cx="320040" cy="256032"/>
+          </a:xfrm>
+          <a:prstGeom prst="roundRect">
+            <a:avLst/>
+          </a:prstGeom>
+          <a:solidFill>
+            <a:srgbClr val="C8E6C9"/>
+          </a:solidFill>
+          <a:ln w="12700">
+            <a:solidFill>
+              <a:srgbClr val="404040"/>
+            </a:solidFill>
+          </a:ln>
+          <a:effectLst/>
+        </p:spPr>
+        <p:style>
+          <a:lnRef idx="1">
+            <a:schemeClr val="accent1"/>
+          </a:lnRef>
+          <a:fillRef idx="3">
+            <a:schemeClr val="accent1"/>
+          </a:fillRef>
+          <a:effectRef idx="2">
+            <a:schemeClr val="accent1"/>
+          </a:effectRef>
+          <a:fontRef idx="minor">
+            <a:schemeClr val="lt1"/>
+          </a:fontRef>
+        </p:style>
+        <p:txBody>
+          <a:bodyPr rtlCol="0" anchor="ctr" wrap="square" lIns="38100" rIns="38100" tIns="25400" bIns="25400"/>
+          <a:lstStyle/>
+          <a:p>
+            <a:pPr algn="ctr">
+              <a:defRPr sz="800" b="1">
+                <a:solidFill>
+                  <a:srgbClr val="1A1A1A"/>
+                </a:solidFill>
+              </a:defRPr>
+            </a:pPr>
+          </a:p>
+        </p:txBody>
+      </p:sp>
+      <p:sp>
+        <p:nvSpPr>
+          <p:cNvPr id="34" name="TextBox 33"/>
+          <p:cNvSpPr txBox="1"/>
+          <p:nvPr/>
+        </p:nvSpPr>
+        <p:spPr>
+          <a:xfrm>
+            <a:off x="4846320" y="5056632"/>
+            <a:ext cx="3200400" cy="274320"/>
+          </a:xfrm>
+          <a:prstGeom prst="rect">
+            <a:avLst/>
+          </a:prstGeom>
+          <a:noFill/>
+        </p:spPr>
+        <p:txBody>
+          <a:bodyPr wrap="none">
+            <a:spAutoFit/>
+          </a:bodyPr>
+          <a:lstStyle/>
+          <a:p>
+            <a:pPr>
+              <a:defRPr sz="1000"/>
+            </a:pPr>
+            <a:r>
+              <a:t>Data &amp; external services layer</a:t>
+            </a:r>
+          </a:p>
+        </p:txBody>
+      </p:sp>
+      <p:sp>
+        <p:nvSpPr>
+          <p:cNvPr id="35" name="TextBox 34"/>
+          <p:cNvSpPr txBox="1"/>
+          <p:nvPr/>
+        </p:nvSpPr>
+        <p:spPr>
+          <a:xfrm>
+            <a:off x="320040" y="5486400"/>
+            <a:ext cx="11551615" cy="1097280"/>
+          </a:xfrm>
+          <a:prstGeom prst="rect">
+            <a:avLst/>
+          </a:prstGeom>
+          <a:noFill/>
+        </p:spPr>
+        <p:txBody>
+          <a:bodyPr wrap="square">
+            <a:spAutoFit/>
+          </a:bodyPr>
+          <a:lstStyle/>
+          <a:p>
+            <a:pPr>
+              <a:defRPr sz="900" i="1">
+                <a:solidFill>
+                  <a:srgbClr val="555555"/>
+                </a:solidFill>
+              </a:defRPr>
+            </a:pPr>
+            <a:r>
+              <a:t>Notes: no static file mount ever serves backend/data/ (photos are private-by-default, streamed through the family-scoped API route). photos.py has no import path into llm.py/prompts.py — photo bytes never enter the LLM prompt (structural isolation, §4.3/§7). Auth seam (get_current_family) sits inside the FastAPI backend from Increment 1; Increment 3 swaps its body for real session auth without changing route signatures.</a:t>
             </a:r>
           </a:p>
         </p:txBody>

</xml_diff>